<commit_message>
slides: add LGBM vs LogReg comparison slides to repeat_4fold_cv.pptx
Three new slides in repeat_4fold_cv.pptx (now 18 slides):
  - LGBM vs LogReg standalone (met & morph, 4-panel spaghetti)
  - LGBM vs LogReg fusion (all_lgbm vs all_logreg vs original all3)
  - Delta bars: LogReg − LGBM for met, morph, fusion

Key findings baked into plots:
  - LogReg beats LGBM for met at all days (+0.01–0.10 BA)
  - LogReg beats LGBM for morph at early days; LGBM overtakes at Dy24+
  - Fusion: LogReg better early/mid, LGBM comparable at late days

Also loads met_morph_lgbm_logreg_kfold.json and fusion_lgbm_vs_logreg.json.

Co-Authored-By: Claude Sonnet 4.6 <noreply@anthropic.com>
</commit_message>
<xml_diff>
--- a/figures/repeat_4fold_cv.pptx
+++ b/figures/repeat_4fold_cv.pptx
@@ -20,6 +20,9 @@
     <p:sldId id="268" r:id="rId19"/>
     <p:sldId id="269" r:id="rId20"/>
     <p:sldId id="270" r:id="rId21"/>
+    <p:sldId id="271" r:id="rId22"/>
+    <p:sldId id="272" r:id="rId23"/>
+    <p:sldId id="273" r:id="rId24"/>
   </p:sldIdLst>
   <p:sldSz cx="12188952" cy="6858000" type="screen4x3"/>
   <p:notesSz cx="6858000" cy="9144000"/>
@@ -3259,7 +3262,7 @@
                   <a:srgbClr val="1F3864"/>
                 </a:solidFill>
               </a:rPr>
-              <a:t>Repeat 5 / 10  (seed = 4001)</a:t>
+              <a:t>Repeat 2 / 10  (seed = 1001)</a:t>
             </a:r>
           </a:p>
         </p:txBody>
@@ -3359,7 +3362,7 @@
                   <a:srgbClr val="1F3864"/>
                 </a:solidFill>
               </a:rPr>
-              <a:t>Repeat 6 / 10  (seed = 5001)</a:t>
+              <a:t>Repeat 3 / 10  (seed = 2001)</a:t>
             </a:r>
           </a:p>
         </p:txBody>
@@ -3459,7 +3462,7 @@
                   <a:srgbClr val="1F3864"/>
                 </a:solidFill>
               </a:rPr>
-              <a:t>Repeat 7 / 10  (seed = 6001)</a:t>
+              <a:t>Repeat 4 / 10  (seed = 3001)</a:t>
             </a:r>
           </a:p>
         </p:txBody>
@@ -3559,7 +3562,7 @@
                   <a:srgbClr val="1F3864"/>
                 </a:solidFill>
               </a:rPr>
-              <a:t>Repeat 8 / 10  (seed = 7001)</a:t>
+              <a:t>Repeat 5 / 10  (seed = 4001)</a:t>
             </a:r>
           </a:p>
         </p:txBody>
@@ -3659,7 +3662,7 @@
                   <a:srgbClr val="1F3864"/>
                 </a:solidFill>
               </a:rPr>
-              <a:t>Repeat 9 / 10  (seed = 8001)</a:t>
+              <a:t>Repeat 6 / 10  (seed = 5001)</a:t>
             </a:r>
           </a:p>
         </p:txBody>
@@ -3721,6 +3724,306 @@
 </file>
 
 <file path=ppt/slides/slide15.xml><?xml version="1.0" encoding="utf-8"?>
+<p:sld xmlns:a="http://schemas.openxmlformats.org/drawingml/2006/main" xmlns:p="http://schemas.openxmlformats.org/presentationml/2006/main" xmlns:r="http://schemas.openxmlformats.org/officeDocument/2006/relationships">
+  <p:cSld>
+    <p:spTree>
+      <p:nvGrpSpPr>
+        <p:cNvPr id="1" name=""/>
+        <p:cNvGrpSpPr/>
+        <p:nvPr/>
+      </p:nvGrpSpPr>
+      <p:grpSpPr/>
+      <p:sp>
+        <p:nvSpPr>
+          <p:cNvPr id="2" name="TextBox 1"/>
+          <p:cNvSpPr txBox="1"/>
+          <p:nvPr/>
+        </p:nvSpPr>
+        <p:spPr>
+          <a:xfrm>
+            <a:off x="320040" y="320040"/>
+            <a:ext cx="11430000" cy="502920"/>
+          </a:xfrm>
+          <a:prstGeom prst="rect">
+            <a:avLst/>
+          </a:prstGeom>
+          <a:noFill/>
+        </p:spPr>
+        <p:txBody>
+          <a:bodyPr wrap="square">
+            <a:spAutoFit/>
+          </a:bodyPr>
+          <a:lstStyle/>
+          <a:p>
+            <a:pPr algn="l"/>
+            <a:r>
+              <a:rPr sz="2200" b="1">
+                <a:solidFill>
+                  <a:srgbClr val="1F3864"/>
+                </a:solidFill>
+              </a:rPr>
+              <a:t>Repeat 7 / 10  (seed = 6001)</a:t>
+            </a:r>
+          </a:p>
+        </p:txBody>
+      </p:sp>
+      <p:pic>
+        <p:nvPicPr>
+          <p:cNvPr id="3" name="Picture 2" descr="image.png"/>
+          <p:cNvPicPr>
+            <a:picLocks noChangeAspect="1"/>
+          </p:cNvPicPr>
+          <p:nvPr/>
+        </p:nvPicPr>
+        <p:blipFill>
+          <a:blip r:embed="rId2"/>
+          <a:stretch>
+            <a:fillRect/>
+          </a:stretch>
+        </p:blipFill>
+        <p:spPr>
+          <a:xfrm>
+            <a:off x="320040" y="640080"/>
+            <a:ext cx="11430000" cy="4064155"/>
+          </a:xfrm>
+          <a:prstGeom prst="rect">
+            <a:avLst/>
+          </a:prstGeom>
+        </p:spPr>
+      </p:pic>
+      <p:pic>
+        <p:nvPicPr>
+          <p:cNvPr id="4" name="Picture 3" descr="image.png"/>
+          <p:cNvPicPr>
+            <a:picLocks noChangeAspect="1"/>
+          </p:cNvPicPr>
+          <p:nvPr/>
+        </p:nvPicPr>
+        <p:blipFill>
+          <a:blip r:embed="rId3"/>
+          <a:stretch>
+            <a:fillRect/>
+          </a:stretch>
+        </p:blipFill>
+        <p:spPr>
+          <a:xfrm>
+            <a:off x="320040" y="4160520"/>
+            <a:ext cx="8686800" cy="2787069"/>
+          </a:xfrm>
+          <a:prstGeom prst="rect">
+            <a:avLst/>
+          </a:prstGeom>
+        </p:spPr>
+      </p:pic>
+    </p:spTree>
+  </p:cSld>
+  <p:clrMapOvr>
+    <a:masterClrMapping/>
+  </p:clrMapOvr>
+</p:sld>
+</file>
+
+<file path=ppt/slides/slide16.xml><?xml version="1.0" encoding="utf-8"?>
+<p:sld xmlns:a="http://schemas.openxmlformats.org/drawingml/2006/main" xmlns:p="http://schemas.openxmlformats.org/presentationml/2006/main" xmlns:r="http://schemas.openxmlformats.org/officeDocument/2006/relationships">
+  <p:cSld>
+    <p:spTree>
+      <p:nvGrpSpPr>
+        <p:cNvPr id="1" name=""/>
+        <p:cNvGrpSpPr/>
+        <p:nvPr/>
+      </p:nvGrpSpPr>
+      <p:grpSpPr/>
+      <p:sp>
+        <p:nvSpPr>
+          <p:cNvPr id="2" name="TextBox 1"/>
+          <p:cNvSpPr txBox="1"/>
+          <p:nvPr/>
+        </p:nvSpPr>
+        <p:spPr>
+          <a:xfrm>
+            <a:off x="320040" y="320040"/>
+            <a:ext cx="11430000" cy="502920"/>
+          </a:xfrm>
+          <a:prstGeom prst="rect">
+            <a:avLst/>
+          </a:prstGeom>
+          <a:noFill/>
+        </p:spPr>
+        <p:txBody>
+          <a:bodyPr wrap="square">
+            <a:spAutoFit/>
+          </a:bodyPr>
+          <a:lstStyle/>
+          <a:p>
+            <a:pPr algn="l"/>
+            <a:r>
+              <a:rPr sz="2200" b="1">
+                <a:solidFill>
+                  <a:srgbClr val="1F3864"/>
+                </a:solidFill>
+              </a:rPr>
+              <a:t>Repeat 8 / 10  (seed = 7001)</a:t>
+            </a:r>
+          </a:p>
+        </p:txBody>
+      </p:sp>
+      <p:pic>
+        <p:nvPicPr>
+          <p:cNvPr id="3" name="Picture 2" descr="image.png"/>
+          <p:cNvPicPr>
+            <a:picLocks noChangeAspect="1"/>
+          </p:cNvPicPr>
+          <p:nvPr/>
+        </p:nvPicPr>
+        <p:blipFill>
+          <a:blip r:embed="rId2"/>
+          <a:stretch>
+            <a:fillRect/>
+          </a:stretch>
+        </p:blipFill>
+        <p:spPr>
+          <a:xfrm>
+            <a:off x="320040" y="640080"/>
+            <a:ext cx="11430000" cy="4064155"/>
+          </a:xfrm>
+          <a:prstGeom prst="rect">
+            <a:avLst/>
+          </a:prstGeom>
+        </p:spPr>
+      </p:pic>
+      <p:pic>
+        <p:nvPicPr>
+          <p:cNvPr id="4" name="Picture 3" descr="image.png"/>
+          <p:cNvPicPr>
+            <a:picLocks noChangeAspect="1"/>
+          </p:cNvPicPr>
+          <p:nvPr/>
+        </p:nvPicPr>
+        <p:blipFill>
+          <a:blip r:embed="rId3"/>
+          <a:stretch>
+            <a:fillRect/>
+          </a:stretch>
+        </p:blipFill>
+        <p:spPr>
+          <a:xfrm>
+            <a:off x="320040" y="4160520"/>
+            <a:ext cx="8686800" cy="2787069"/>
+          </a:xfrm>
+          <a:prstGeom prst="rect">
+            <a:avLst/>
+          </a:prstGeom>
+        </p:spPr>
+      </p:pic>
+    </p:spTree>
+  </p:cSld>
+  <p:clrMapOvr>
+    <a:masterClrMapping/>
+  </p:clrMapOvr>
+</p:sld>
+</file>
+
+<file path=ppt/slides/slide17.xml><?xml version="1.0" encoding="utf-8"?>
+<p:sld xmlns:a="http://schemas.openxmlformats.org/drawingml/2006/main" xmlns:p="http://schemas.openxmlformats.org/presentationml/2006/main" xmlns:r="http://schemas.openxmlformats.org/officeDocument/2006/relationships">
+  <p:cSld>
+    <p:spTree>
+      <p:nvGrpSpPr>
+        <p:cNvPr id="1" name=""/>
+        <p:cNvGrpSpPr/>
+        <p:nvPr/>
+      </p:nvGrpSpPr>
+      <p:grpSpPr/>
+      <p:sp>
+        <p:nvSpPr>
+          <p:cNvPr id="2" name="TextBox 1"/>
+          <p:cNvSpPr txBox="1"/>
+          <p:nvPr/>
+        </p:nvSpPr>
+        <p:spPr>
+          <a:xfrm>
+            <a:off x="320040" y="320040"/>
+            <a:ext cx="11430000" cy="502920"/>
+          </a:xfrm>
+          <a:prstGeom prst="rect">
+            <a:avLst/>
+          </a:prstGeom>
+          <a:noFill/>
+        </p:spPr>
+        <p:txBody>
+          <a:bodyPr wrap="square">
+            <a:spAutoFit/>
+          </a:bodyPr>
+          <a:lstStyle/>
+          <a:p>
+            <a:pPr algn="l"/>
+            <a:r>
+              <a:rPr sz="2200" b="1">
+                <a:solidFill>
+                  <a:srgbClr val="1F3864"/>
+                </a:solidFill>
+              </a:rPr>
+              <a:t>Repeat 9 / 10  (seed = 8001)</a:t>
+            </a:r>
+          </a:p>
+        </p:txBody>
+      </p:sp>
+      <p:pic>
+        <p:nvPicPr>
+          <p:cNvPr id="3" name="Picture 2" descr="image.png"/>
+          <p:cNvPicPr>
+            <a:picLocks noChangeAspect="1"/>
+          </p:cNvPicPr>
+          <p:nvPr/>
+        </p:nvPicPr>
+        <p:blipFill>
+          <a:blip r:embed="rId2"/>
+          <a:stretch>
+            <a:fillRect/>
+          </a:stretch>
+        </p:blipFill>
+        <p:spPr>
+          <a:xfrm>
+            <a:off x="320040" y="640080"/>
+            <a:ext cx="11430000" cy="4064155"/>
+          </a:xfrm>
+          <a:prstGeom prst="rect">
+            <a:avLst/>
+          </a:prstGeom>
+        </p:spPr>
+      </p:pic>
+      <p:pic>
+        <p:nvPicPr>
+          <p:cNvPr id="4" name="Picture 3" descr="image.png"/>
+          <p:cNvPicPr>
+            <a:picLocks noChangeAspect="1"/>
+          </p:cNvPicPr>
+          <p:nvPr/>
+        </p:nvPicPr>
+        <p:blipFill>
+          <a:blip r:embed="rId3"/>
+          <a:stretch>
+            <a:fillRect/>
+          </a:stretch>
+        </p:blipFill>
+        <p:spPr>
+          <a:xfrm>
+            <a:off x="320040" y="4160520"/>
+            <a:ext cx="8686800" cy="2787069"/>
+          </a:xfrm>
+          <a:prstGeom prst="rect">
+            <a:avLst/>
+          </a:prstGeom>
+        </p:spPr>
+      </p:pic>
+    </p:spTree>
+  </p:cSld>
+  <p:clrMapOvr>
+    <a:masterClrMapping/>
+  </p:clrMapOvr>
+</p:sld>
+</file>
+
+<file path=ppt/slides/slide18.xml><?xml version="1.0" encoding="utf-8"?>
 <p:sld xmlns:a="http://schemas.openxmlformats.org/drawingml/2006/main" xmlns:p="http://schemas.openxmlformats.org/presentationml/2006/main" xmlns:r="http://schemas.openxmlformats.org/officeDocument/2006/relationships">
   <p:cSld>
     <p:spTree>
@@ -4190,7 +4493,7 @@
                   <a:srgbClr val="1F3864"/>
                 </a:solidFill>
               </a:rPr>
-              <a:t>Repeat 1 / 10  (seed = 1)</a:t>
+              <a:t>LGBM vs LogReg — Standalone (Met &amp; Morphology)</a:t>
             </a:r>
           </a:p>
         </p:txBody>
@@ -4211,32 +4514,8 @@
         </p:blipFill>
         <p:spPr>
           <a:xfrm>
-            <a:off x="320040" y="640080"/>
-            <a:ext cx="11430000" cy="4064155"/>
-          </a:xfrm>
-          <a:prstGeom prst="rect">
-            <a:avLst/>
-          </a:prstGeom>
-        </p:spPr>
-      </p:pic>
-      <p:pic>
-        <p:nvPicPr>
-          <p:cNvPr id="4" name="Picture 3" descr="image.png"/>
-          <p:cNvPicPr>
-            <a:picLocks noChangeAspect="1"/>
-          </p:cNvPicPr>
-          <p:nvPr/>
-        </p:nvPicPr>
-        <p:blipFill>
-          <a:blip r:embed="rId3"/>
-          <a:stretch>
-            <a:fillRect/>
-          </a:stretch>
-        </p:blipFill>
-        <p:spPr>
-          <a:xfrm>
-            <a:off x="320040" y="4160520"/>
-            <a:ext cx="8686800" cy="2787069"/>
+            <a:off x="320040" y="685800"/>
+            <a:ext cx="11430000" cy="2637103"/>
           </a:xfrm>
           <a:prstGeom prst="rect">
             <a:avLst/>
@@ -4290,7 +4569,7 @@
                   <a:srgbClr val="1F3864"/>
                 </a:solidFill>
               </a:rPr>
-              <a:t>Repeat 2 / 10  (seed = 1001)</a:t>
+              <a:t>LGBM vs LogReg — Fusion (met + morph + img mean prob)</a:t>
             </a:r>
           </a:p>
         </p:txBody>
@@ -4311,32 +4590,8 @@
         </p:blipFill>
         <p:spPr>
           <a:xfrm>
-            <a:off x="320040" y="640080"/>
-            <a:ext cx="11430000" cy="4064155"/>
-          </a:xfrm>
-          <a:prstGeom prst="rect">
-            <a:avLst/>
-          </a:prstGeom>
-        </p:spPr>
-      </p:pic>
-      <p:pic>
-        <p:nvPicPr>
-          <p:cNvPr id="4" name="Picture 3" descr="image.png"/>
-          <p:cNvPicPr>
-            <a:picLocks noChangeAspect="1"/>
-          </p:cNvPicPr>
-          <p:nvPr/>
-        </p:nvPicPr>
-        <p:blipFill>
-          <a:blip r:embed="rId3"/>
-          <a:stretch>
-            <a:fillRect/>
-          </a:stretch>
-        </p:blipFill>
-        <p:spPr>
-          <a:xfrm>
-            <a:off x="320040" y="4160520"/>
-            <a:ext cx="8686800" cy="2787069"/>
+            <a:off x="320040" y="685800"/>
+            <a:ext cx="11430000" cy="4683481"/>
           </a:xfrm>
           <a:prstGeom prst="rect">
             <a:avLst/>
@@ -4390,7 +4645,7 @@
                   <a:srgbClr val="1F3864"/>
                 </a:solidFill>
               </a:rPr>
-              <a:t>Repeat 3 / 10  (seed = 2001)</a:t>
+              <a:t>LogReg − LGBM Delta: Where Does Classifier Choice Matter?</a:t>
             </a:r>
           </a:p>
         </p:txBody>
@@ -4411,32 +4666,8 @@
         </p:blipFill>
         <p:spPr>
           <a:xfrm>
-            <a:off x="320040" y="640080"/>
-            <a:ext cx="11430000" cy="4064155"/>
-          </a:xfrm>
-          <a:prstGeom prst="rect">
-            <a:avLst/>
-          </a:prstGeom>
-        </p:spPr>
-      </p:pic>
-      <p:pic>
-        <p:nvPicPr>
-          <p:cNvPr id="4" name="Picture 3" descr="image.png"/>
-          <p:cNvPicPr>
-            <a:picLocks noChangeAspect="1"/>
-          </p:cNvPicPr>
-          <p:nvPr/>
-        </p:nvPicPr>
-        <p:blipFill>
-          <a:blip r:embed="rId3"/>
-          <a:stretch>
-            <a:fillRect/>
-          </a:stretch>
-        </p:blipFill>
-        <p:spPr>
-          <a:xfrm>
-            <a:off x="320040" y="4160520"/>
-            <a:ext cx="8686800" cy="2787069"/>
+            <a:off x="320040" y="685800"/>
+            <a:ext cx="11430000" cy="2610503"/>
           </a:xfrm>
           <a:prstGeom prst="rect">
             <a:avLst/>
@@ -4490,7 +4721,7 @@
                   <a:srgbClr val="1F3864"/>
                 </a:solidFill>
               </a:rPr>
-              <a:t>Repeat 4 / 10  (seed = 3001)</a:t>
+              <a:t>Repeat 1 / 10  (seed = 1)</a:t>
             </a:r>
           </a:p>
         </p:txBody>

</xml_diff>